<commit_message>
Presentación: detalle de los algoritmos (qué, cómo y por qué frente a las alternativas)
9 diapositivas nuevas, todo sacado de la memoria entregada: mapa de algoritmos, pose 2D
(Tablas 1 y 2), 3D con MotionBERT (Tabla 14), vista automática y señales de brazada,
Isolation Forest frente a red recurrente, sensibilidad del umbral (Tabla 12) y PELT,
TreeSHAP, estilo (XGBoost -> bosque aleatorio -> reglas) y cambios del apartado 5.2.

Co-Authored-By: Claude Opus 5.5 <noreply@anthropic.com>
Claude-Session: https://claude.ai/code/session_01DiSvbFm8ugCvoNLrXeNJkq
</commit_message>
<xml_diff>
--- a/presentacion/StrokeLab_posterior_entrega.pptx
+++ b/presentacion/StrokeLab_posterior_entrega.pptx
@@ -9,10 +9,10 @@
   </p:notesMasterIdLst>
   <p:sldIdLst>
     <p:sldId id="318" r:id="rId2"/>
-    <p:sldId id="331" r:id="rId23"/>
-    <p:sldId id="337" r:id="rId29"/>
-    <p:sldId id="338" r:id="rId30"/>
-    <p:sldId id="339" r:id="rId31"/>
+    <p:sldId id="340" r:id="rId32"/>
+    <p:sldId id="346" r:id="rId38"/>
+    <p:sldId id="347" r:id="rId39"/>
+    <p:sldId id="348" r:id="rId40"/>
   </p:sldIdLst>
   <p:sldSz cx="14630400" cy="8229600"/>
   <p:notesSz cx="6858000" cy="9144000"/>
@@ -773,7 +773,7 @@
 </p:notes>
 </file>
 
-<file path=ppt/notesSlides/notesSlide14.xml><?xml version="1.0" encoding="utf-8"?>
+<file path=ppt/notesSlides/notesSlide23.xml><?xml version="1.0" encoding="utf-8"?>
 <p:notes xmlns:a="http://schemas.openxmlformats.org/drawingml/2006/main" xmlns:p="http://schemas.openxmlformats.org/presentationml/2006/main" xmlns:r="http://schemas.openxmlformats.org/officeDocument/2006/relationships">
   <p:cSld>
     <p:spTree>
@@ -843,7 +843,7 @@
 </p:notes>
 </file>
 
-<file path=ppt/notesSlides/notesSlide19.xml><?xml version="1.0" encoding="utf-8"?>
+<file path=ppt/notesSlides/notesSlide28.xml><?xml version="1.0" encoding="utf-8"?>
 <p:notes xmlns:a="http://schemas.openxmlformats.org/drawingml/2006/main" xmlns:p="http://schemas.openxmlformats.org/presentationml/2006/main" xmlns:r="http://schemas.openxmlformats.org/officeDocument/2006/relationships">
   <p:cSld>
     <p:spTree>
@@ -913,7 +913,7 @@
 </p:notes>
 </file>
 
-<file path=ppt/notesSlides/notesSlide20.xml><?xml version="1.0" encoding="utf-8"?>
+<file path=ppt/notesSlides/notesSlide29.xml><?xml version="1.0" encoding="utf-8"?>
 <p:notes xmlns:a="http://schemas.openxmlformats.org/drawingml/2006/main" xmlns:p="http://schemas.openxmlformats.org/presentationml/2006/main" xmlns:r="http://schemas.openxmlformats.org/officeDocument/2006/relationships">
   <p:cSld>
     <p:spTree>
@@ -983,7 +983,7 @@
 </p:notes>
 </file>
 
-<file path=ppt/notesSlides/notesSlide21.xml><?xml version="1.0" encoding="utf-8"?>
+<file path=ppt/notesSlides/notesSlide30.xml><?xml version="1.0" encoding="utf-8"?>
 <p:notes xmlns:a="http://schemas.openxmlformats.org/drawingml/2006/main" xmlns:p="http://schemas.openxmlformats.org/presentationml/2006/main" xmlns:r="http://schemas.openxmlformats.org/officeDocument/2006/relationships">
   <p:cSld>
     <p:spTree>
@@ -56239,7 +56239,7 @@
 </p:sld>
 </file>
 
-<file path=ppt/slides/slide14.xml><?xml version="1.0" encoding="utf-8"?>
+<file path=ppt/slides/slide23.xml><?xml version="1.0" encoding="utf-8"?>
 <p:sld xmlns:a="http://schemas.openxmlformats.org/drawingml/2006/main" xmlns:p="http://schemas.openxmlformats.org/presentationml/2006/main" xmlns:r="http://schemas.openxmlformats.org/officeDocument/2006/relationships">
   <p:cSld>
     <p:spTree>
@@ -56668,7 +56668,7 @@
 </p:sld>
 </file>
 
-<file path=ppt/slides/slide20.xml><?xml version="1.0" encoding="utf-8"?>
+<file path=ppt/slides/slide29.xml><?xml version="1.0" encoding="utf-8"?>
 <p:sld xmlns:a="http://schemas.openxmlformats.org/drawingml/2006/main" xmlns:p="http://schemas.openxmlformats.org/presentationml/2006/main" xmlns:r="http://schemas.openxmlformats.org/officeDocument/2006/relationships">
   <p:cSld>
     <p:spTree>
@@ -57573,7 +57573,7 @@
 </p:sld>
 </file>
 
-<file path=ppt/slides/slide21.xml><?xml version="1.0" encoding="utf-8"?>
+<file path=ppt/slides/slide30.xml><?xml version="1.0" encoding="utf-8"?>
 <p:sld xmlns:a="http://schemas.openxmlformats.org/drawingml/2006/main" xmlns:p="http://schemas.openxmlformats.org/presentationml/2006/main" xmlns:r="http://schemas.openxmlformats.org/officeDocument/2006/relationships">
   <p:cSld>
     <p:spTree>
@@ -58180,7 +58180,7 @@
 </p:sld>
 </file>
 
-<file path=ppt/slides/slide22.xml><?xml version="1.0" encoding="utf-8"?>
+<file path=ppt/slides/slide31.xml><?xml version="1.0" encoding="utf-8"?>
 <p:sld xmlns:a="http://schemas.openxmlformats.org/drawingml/2006/main" xmlns:p="http://schemas.openxmlformats.org/presentationml/2006/main" xmlns:r="http://schemas.openxmlformats.org/officeDocument/2006/relationships">
   <p:cSld>
     <p:spTree>

</xml_diff>

<commit_message>
Presentación de 12 diapositivas para 15 minutos; detalle de algoritmos en un archivo de apoyo
La defensa queda en 12 diapositivas (portada y cierre incluidos), con los algoritmos resumidos:
tabla de qué se eligió y por qué, visión, ciclos, fatiga, SHAP, cambios y resultados. Las
diapositivas detalladas y los anexos pasan a StrokeLab_apoyo_preguntas.pptx.

Co-Authored-By: Claude Opus 5.5 <noreply@anthropic.com>
Claude-Session: https://claude.ai/code/session_01DiSvbFm8ugCvoNLrXeNJkq
</commit_message>
<xml_diff>
--- a/presentacion/StrokeLab_posterior_entrega.pptx
+++ b/presentacion/StrokeLab_posterior_entrega.pptx
@@ -10,9 +10,9 @@
   <p:sldIdLst>
     <p:sldId id="318" r:id="rId2"/>
     <p:sldId id="340" r:id="rId32"/>
-    <p:sldId id="346" r:id="rId38"/>
-    <p:sldId id="347" r:id="rId39"/>
-    <p:sldId id="348" r:id="rId40"/>
+    <p:sldId id="353" r:id="rId45"/>
+    <p:sldId id="354" r:id="rId46"/>
+    <p:sldId id="355" r:id="rId47"/>
   </p:sldIdLst>
   <p:sldSz cx="14630400" cy="8229600"/>
   <p:notesSz cx="6858000" cy="9144000"/>
@@ -843,7 +843,7 @@
 </p:notes>
 </file>
 
-<file path=ppt/notesSlides/notesSlide28.xml><?xml version="1.0" encoding="utf-8"?>
+<file path=ppt/notesSlides/notesSlide35.xml><?xml version="1.0" encoding="utf-8"?>
 <p:notes xmlns:a="http://schemas.openxmlformats.org/drawingml/2006/main" xmlns:p="http://schemas.openxmlformats.org/presentationml/2006/main" xmlns:r="http://schemas.openxmlformats.org/officeDocument/2006/relationships">
   <p:cSld>
     <p:spTree>
@@ -913,7 +913,7 @@
 </p:notes>
 </file>
 
-<file path=ppt/notesSlides/notesSlide29.xml><?xml version="1.0" encoding="utf-8"?>
+<file path=ppt/notesSlides/notesSlide36.xml><?xml version="1.0" encoding="utf-8"?>
 <p:notes xmlns:a="http://schemas.openxmlformats.org/drawingml/2006/main" xmlns:p="http://schemas.openxmlformats.org/presentationml/2006/main" xmlns:r="http://schemas.openxmlformats.org/officeDocument/2006/relationships">
   <p:cSld>
     <p:spTree>
@@ -983,7 +983,7 @@
 </p:notes>
 </file>
 
-<file path=ppt/notesSlides/notesSlide30.xml><?xml version="1.0" encoding="utf-8"?>
+<file path=ppt/notesSlides/notesSlide37.xml><?xml version="1.0" encoding="utf-8"?>
 <p:notes xmlns:a="http://schemas.openxmlformats.org/drawingml/2006/main" xmlns:p="http://schemas.openxmlformats.org/presentationml/2006/main" xmlns:r="http://schemas.openxmlformats.org/officeDocument/2006/relationships">
   <p:cSld>
     <p:spTree>
@@ -56668,7 +56668,7 @@
 </p:sld>
 </file>
 
-<file path=ppt/slides/slide29.xml><?xml version="1.0" encoding="utf-8"?>
+<file path=ppt/slides/slide36.xml><?xml version="1.0" encoding="utf-8"?>
 <p:sld xmlns:a="http://schemas.openxmlformats.org/drawingml/2006/main" xmlns:p="http://schemas.openxmlformats.org/presentationml/2006/main" xmlns:r="http://schemas.openxmlformats.org/officeDocument/2006/relationships">
   <p:cSld>
     <p:spTree>
@@ -57573,7 +57573,7 @@
 </p:sld>
 </file>
 
-<file path=ppt/slides/slide30.xml><?xml version="1.0" encoding="utf-8"?>
+<file path=ppt/slides/slide37.xml><?xml version="1.0" encoding="utf-8"?>
 <p:sld xmlns:a="http://schemas.openxmlformats.org/drawingml/2006/main" xmlns:p="http://schemas.openxmlformats.org/presentationml/2006/main" xmlns:r="http://schemas.openxmlformats.org/officeDocument/2006/relationships">
   <p:cSld>
     <p:spTree>
@@ -58180,7 +58180,7 @@
 </p:sld>
 </file>
 
-<file path=ppt/slides/slide31.xml><?xml version="1.0" encoding="utf-8"?>
+<file path=ppt/slides/slide38.xml><?xml version="1.0" encoding="utf-8"?>
 <p:sld xmlns:a="http://schemas.openxmlformats.org/drawingml/2006/main" xmlns:p="http://schemas.openxmlformats.org/presentationml/2006/main" xmlns:r="http://schemas.openxmlformats.org/officeDocument/2006/relationships">
   <p:cSld>
     <p:spTree>

</xml_diff>

<commit_message>
Presentación reorganizada con el esquema de defensa de la UE
Problema y estado del arte (con preguntas de investigación), objetivo y aportación, método y
datos, capas (visión, ciclos, fatiga, SHAP), resultados frente a los objetivos, demostración,
alcance y conclusiones. 12 diapositivas, contenido solo de la memoria; la arquitectura, los
cambios del apartado 5.2 y los resultados en cifras pasan al archivo de apoyo.

Co-Authored-By: Claude Opus 5.5 <noreply@anthropic.com>
Claude-Session: https://claude.ai/code/session_01DiSvbFm8ugCvoNLrXeNJkq
</commit_message>
<xml_diff>
--- a/presentacion/StrokeLab_posterior_entrega.pptx
+++ b/presentacion/StrokeLab_posterior_entrega.pptx
@@ -10,9 +10,9 @@
   <p:sldIdLst>
     <p:sldId id="318" r:id="rId2"/>
     <p:sldId id="340" r:id="rId32"/>
-    <p:sldId id="353" r:id="rId45"/>
-    <p:sldId id="354" r:id="rId46"/>
-    <p:sldId id="355" r:id="rId47"/>
+    <p:sldId id="357" r:id="rId49"/>
+    <p:sldId id="358" r:id="rId50"/>
+    <p:sldId id="359" r:id="rId51"/>
   </p:sldIdLst>
   <p:sldSz cx="14630400" cy="8229600"/>
   <p:notesSz cx="6858000" cy="9144000"/>
@@ -843,7 +843,7 @@
 </p:notes>
 </file>
 
-<file path=ppt/notesSlides/notesSlide35.xml><?xml version="1.0" encoding="utf-8"?>
+<file path=ppt/notesSlides/notesSlide39.xml><?xml version="1.0" encoding="utf-8"?>
 <p:notes xmlns:a="http://schemas.openxmlformats.org/drawingml/2006/main" xmlns:p="http://schemas.openxmlformats.org/presentationml/2006/main" xmlns:r="http://schemas.openxmlformats.org/officeDocument/2006/relationships">
   <p:cSld>
     <p:spTree>
@@ -913,7 +913,7 @@
 </p:notes>
 </file>
 
-<file path=ppt/notesSlides/notesSlide36.xml><?xml version="1.0" encoding="utf-8"?>
+<file path=ppt/notesSlides/notesSlide40.xml><?xml version="1.0" encoding="utf-8"?>
 <p:notes xmlns:a="http://schemas.openxmlformats.org/drawingml/2006/main" xmlns:p="http://schemas.openxmlformats.org/presentationml/2006/main" xmlns:r="http://schemas.openxmlformats.org/officeDocument/2006/relationships">
   <p:cSld>
     <p:spTree>
@@ -983,7 +983,7 @@
 </p:notes>
 </file>
 
-<file path=ppt/notesSlides/notesSlide37.xml><?xml version="1.0" encoding="utf-8"?>
+<file path=ppt/notesSlides/notesSlide41.xml><?xml version="1.0" encoding="utf-8"?>
 <p:notes xmlns:a="http://schemas.openxmlformats.org/drawingml/2006/main" xmlns:p="http://schemas.openxmlformats.org/presentationml/2006/main" xmlns:r="http://schemas.openxmlformats.org/officeDocument/2006/relationships">
   <p:cSld>
     <p:spTree>
@@ -56668,7 +56668,7 @@
 </p:sld>
 </file>
 
-<file path=ppt/slides/slide36.xml><?xml version="1.0" encoding="utf-8"?>
+<file path=ppt/slides/slide40.xml><?xml version="1.0" encoding="utf-8"?>
 <p:sld xmlns:a="http://schemas.openxmlformats.org/drawingml/2006/main" xmlns:p="http://schemas.openxmlformats.org/presentationml/2006/main" xmlns:r="http://schemas.openxmlformats.org/officeDocument/2006/relationships">
   <p:cSld>
     <p:spTree>
@@ -57573,7 +57573,7 @@
 </p:sld>
 </file>
 
-<file path=ppt/slides/slide37.xml><?xml version="1.0" encoding="utf-8"?>
+<file path=ppt/slides/slide41.xml><?xml version="1.0" encoding="utf-8"?>
 <p:sld xmlns:a="http://schemas.openxmlformats.org/drawingml/2006/main" xmlns:p="http://schemas.openxmlformats.org/presentationml/2006/main" xmlns:r="http://schemas.openxmlformats.org/officeDocument/2006/relationships">
   <p:cSld>
     <p:spTree>
@@ -58180,7 +58180,7 @@
 </p:sld>
 </file>
 
-<file path=ppt/slides/slide38.xml><?xml version="1.0" encoding="utf-8"?>
+<file path=ppt/slides/slide42.xml><?xml version="1.0" encoding="utf-8"?>
 <p:sld xmlns:a="http://schemas.openxmlformats.org/drawingml/2006/main" xmlns:p="http://schemas.openxmlformats.org/presentationml/2006/main" xmlns:r="http://schemas.openxmlformats.org/officeDocument/2006/relationships">
   <p:cSld>
     <p:spTree>

</xml_diff>

<commit_message>
Presentación de 15 diapositivas: guion, estilo y validación sintética
Se añaden el guion, el estilo (supervisado -> reglas) y la validación con datos sintéticos.
El tiempo de cada diapositiva en las notas se calcula con su texto (≈ 13 min en total).

Co-Authored-By: Claude Opus 5.5 <noreply@anthropic.com>
Claude-Session: https://claude.ai/code/session_01DiSvbFm8ugCvoNLrXeNJkq
</commit_message>
<xml_diff>
--- a/presentacion/StrokeLab_posterior_entrega.pptx
+++ b/presentacion/StrokeLab_posterior_entrega.pptx
@@ -748,7 +748,7 @@
           <a:lstStyle/>
           <a:p>
             <a:r>
-              <a:t>Buenos días. Soy Diana Cruz y presento StrokeLab, un sistema que analiza un vídeo de natación y le dice al entrenador cómo de eficiente es la brazada, en qué momento aparece la fatiga técnica y por qué. Todo funciona con una cámara normal y un portátil sin GPU. [≈ 20 s]</a:t>
+              <a:t>Buenos días. Soy Diana Cruz y presento StrokeLab, un sistema que analiza un vídeo de natación y le dice al entrenador cómo de eficiente es la brazada, en qué momento aparece la fatiga técnica y por qué. Todo funciona con una cámara normal y un portátil sin GPU. [≈ 30 s]</a:t>
             </a:r>
           </a:p>
         </p:txBody>
@@ -818,7 +818,7 @@
           <a:lstStyle/>
           <a:p>
             <a:r>
-              <a:t>Después de entregar quise atacar la principal limitación, la detección bajo el agua. Usé 405 imágenes reales de nadadores anotadas, públicas, y evalué con validación cruzada de cuatro pliegues separando por grabación para que no haya fuga de datos. El modelo ajustado detecta al nadador en el 78 % de las imágenes frente al 47 % del original, y el OKS sube de 0,10 a 0,40. Probé también modelos más grandes y datos sintéticos: no mejoran, lo que confirma que el límite son los datos reales del dominio. Y aplicado a mis vídeos aumenta el tiempo analizable un 26 %, pero la frecuencia no mejora: las reglas posteriores están calibradas con el modelo original y hay que recalibrarlas. Por eso el sistema de la memoria sigue con el modelo original. [≈ 1 min 30 s]</a:t>
+              <a:t>Después de entregar quise atacar la principal limitación, la detección bajo el agua. Usé 405 imágenes reales de nadadores anotadas, públicas, y evalué con validación cruzada de cuatro pliegues separando por grabación para que no haya fuga de datos. El modelo ajustado detecta al nadador en el 78 % de las imágenes frente al 47 % del original, y el OKS sube de 0,10 a 0,40. Probé también modelos más grandes y datos sintéticos: no mejoran, lo que confirma que el límite son los datos reales del dominio. Y aplicado a mis vídeos aumenta el tiempo analizable un 26 %, pero la frecuencia no mejora: las reglas posteriores están calibradas con el modelo original y hay que recalibrarlas. Por eso el sistema de la memoria sigue con el modelo original. [≈ 1 min 5 s]</a:t>
             </a:r>
           </a:p>
         </p:txBody>

</xml_diff>

<commit_message>
Presentación: títulos visibles en PowerPoint y texto general del problema y del objetivo
Los títulos y subtítulos se guardaban con alto 0 y sin posición (PowerPoint no los mostraba);
ahora llevan posición y tamaño completos. Problema y objetivo con su enunciado de la memoria.

Co-Authored-By: Claude Opus 5.5 <noreply@anthropic.com>
Claude-Session: https://claude.ai/code/session_01DiSvbFm8ugCvoNLrXeNJkq
</commit_message>
<xml_diff>
--- a/presentacion/StrokeLab_posterior_entrega.pptx
+++ b/presentacion/StrokeLab_posterior_entrega.pptx
@@ -56261,7 +56261,8 @@
         </p:nvSpPr>
         <p:spPr>
           <a:xfrm>
-            <a:ext cx="10789920" cy="0"/>
+            <a:off x="906463" y="1182159"/>
+            <a:ext cx="10789920" cy="703086"/>
           </a:xfrm>
         </p:spPr>
         <p:txBody>
@@ -56287,7 +56288,8 @@
         </p:nvSpPr>
         <p:spPr>
           <a:xfrm>
-            <a:ext cx="12344400" cy="0"/>
+            <a:off x="906463" y="2172974"/>
+            <a:ext cx="12344400" cy="594092"/>
           </a:xfrm>
         </p:spPr>
         <p:txBody>
@@ -56690,7 +56692,8 @@
         </p:nvSpPr>
         <p:spPr>
           <a:xfrm>
-            <a:ext cx="10789920" cy="0"/>
+            <a:off x="906463" y="1182159"/>
+            <a:ext cx="10789920" cy="703086"/>
           </a:xfrm>
         </p:spPr>
         <p:txBody>
@@ -56716,7 +56719,8 @@
         </p:nvSpPr>
         <p:spPr>
           <a:xfrm>
-            <a:ext cx="12344400" cy="0"/>
+            <a:off x="906463" y="2172974"/>
+            <a:ext cx="12344400" cy="594092"/>
           </a:xfrm>
         </p:spPr>
         <p:txBody>
@@ -57595,7 +57599,8 @@
         </p:nvSpPr>
         <p:spPr>
           <a:xfrm>
-            <a:ext cx="10789920" cy="0"/>
+            <a:off x="906463" y="1182159"/>
+            <a:ext cx="10789920" cy="703086"/>
           </a:xfrm>
         </p:spPr>
         <p:txBody>
@@ -57621,7 +57626,8 @@
         </p:nvSpPr>
         <p:spPr>
           <a:xfrm>
-            <a:ext cx="12344400" cy="0"/>
+            <a:off x="906463" y="2172974"/>
+            <a:ext cx="12344400" cy="594092"/>
           </a:xfrm>
         </p:spPr>
         <p:txBody>
@@ -58202,7 +58208,8 @@
         </p:nvSpPr>
         <p:spPr>
           <a:xfrm>
-            <a:ext cx="10789920" cy="0"/>
+            <a:off x="906463" y="1182159"/>
+            <a:ext cx="10789920" cy="703086"/>
           </a:xfrm>
         </p:spPr>
         <p:txBody>
@@ -58228,7 +58235,8 @@
         </p:nvSpPr>
         <p:spPr>
           <a:xfrm>
-            <a:ext cx="12344400" cy="0"/>
+            <a:off x="906463" y="2172974"/>
+            <a:ext cx="12344400" cy="594092"/>
           </a:xfrm>
         </p:spPr>
         <p:txBody>

</xml_diff>